<commit_message>
Hackathon submission: Zions DevKick - Centralized Developer Assistant
- Chrome/Edge side panel extension with 4 tabs (Chat, Review, Tickets, Actions)
- FastAPI backend with RAG pipeline (LangChain + ChromaDB + Google Gemini)
- AI-powered troubleshooting, PR code review, ServiceNow integration
- Presentation and speaker notes included
</commit_message>
<xml_diff>
--- a/Zions_DevKick_Hackathon_Presentation.pptx
+++ b/Zions_DevKick_Hackathon_Presentation.pptx
@@ -5535,7 +5535,7 @@
               </a:defRPr>
             </a:pPr>
             <a:r>
-              <a:t>Slack/Teams notifications</a:t>
+              <a:t>Teams notifications</a:t>
             </a:r>
           </a:p>
         </p:txBody>
@@ -5772,7 +5772,7 @@
               </a:defRPr>
             </a:pPr>
             <a:r>
-              <a:t>On-prem LLM option (Ollama)</a:t>
+              <a:t>Google Enterprise AI integration</a:t>
             </a:r>
           </a:p>
         </p:txBody>
@@ -7036,7 +7036,7 @@
               </a:defRPr>
             </a:pPr>
             <a:r>
-              <a:t>Terraform GCP 403 errors lead to 30+ minutes of searching Confluence, Slack, and asking teammates</a:t>
+              <a:t>Terraform GCP 403 errors lead to 30+ minutes of searching Confluence, Teams, and asking teammates</a:t>
             </a:r>
           </a:p>
         </p:txBody>
@@ -9369,7 +9369,7 @@
               </a:defRPr>
             </a:pPr>
             <a:r>
-              <a:t>AI reviews against Zions security standards (CKV policies, CMEK, IAM, network)</a:t>
+              <a:t>AI reviews against Zions security standards (IAM, network, encryption, secrets)</a:t>
             </a:r>
           </a:p>
         </p:txBody>
@@ -12274,7 +12274,7 @@
               </a:defRPr>
             </a:pPr>
             <a:r>
-              <a:t>OpenAI GPT-4o-mini</a:t>
+              <a:t>Google Gemini 3</a:t>
             </a:r>
           </a:p>
         </p:txBody>
@@ -13484,7 +13484,7 @@
             <a:br/>
             <a:br/>
             <a:r>
-              <a:t>Normally: 30+ minutes hunting through Confluence and Slack.</a:t>
+              <a:t>Normally: 30+ minutes hunting through Confluence and Teams.</a:t>
             </a:r>
           </a:p>
         </p:txBody>
@@ -16302,7 +16302,7 @@
               </a:defRPr>
             </a:pPr>
             <a:r>
-              <a:t>Automated PR reviews enforce Zions security standards (CKV policies, CMEK encryption, IAM least privilege, network rules). Security issues caught at code review stage, not in production audit.</a:t>
+              <a:t>Automated PR reviews enforce Zions security standards (IAM least privilege, encryption at rest, network rules, secrets management). Security issues caught at code review stage, not in production audit.</a:t>
             </a:r>
           </a:p>
         </p:txBody>
@@ -17377,7 +17377,7 @@
               </a:defRPr>
             </a:pPr>
             <a:r>
-              <a:t>One-click PR analysis checks Terraform code against Zions-specific security policies: CKV_GCP_24 (encryption), CKV_GCP_38 (no public IPs), CKV_GCP_2 (firewalls), CKV_GCP_11 (VPC flow logs). Returns structured results with severity, fixes, and an overall quality score.</a:t>
+              <a:t>One-click PR analysis checks Terraform code against Zions-specific security policies: encryption at rest, no public IPs, firewall rules, VPC flow logs, hardcoded secrets detection. Returns structured results with severity, fixes, and an overall quality score.</a:t>
             </a:r>
           </a:p>
         </p:txBody>
@@ -17731,7 +17731,7 @@
               </a:defRPr>
             </a:pPr>
             <a:r>
-              <a:t>React 18  |  TypeScript  |  Tailwind CSS  |  Vite 6  |  FastAPI  |  LangChain  |  ChromaDB  |  OpenAI GPT-4o-mini</a:t>
+              <a:t>React 18  |  TypeScript  |  Tailwind CSS  |  Vite 6  |  FastAPI  |  LangChain  |  ChromaDB  |  Google Gemini 3</a:t>
             </a:r>
           </a:p>
         </p:txBody>
@@ -19820,7 +19820,7 @@
               </a:defRPr>
             </a:pPr>
             <a:r>
-              <a:t>Works with OpenAI, Gemini (drop-in), or any OpenAI-compatible API</a:t>
+              <a:t>Works with Gemini, OpenAI (drop-in), or any compatible API</a:t>
             </a:r>
           </a:p>
         </p:txBody>

</xml_diff>